<commit_message>
Product- Working with create form (part-2)
</commit_message>
<xml_diff>
--- a/.lessons/58 Backend Product And Related Features/10 Product- Working with create form (part-2)/1.pptx
+++ b/.lessons/58 Backend Product And Related Features/10 Product- Working with create form (part-2)/1.pptx
@@ -5,9 +5,14 @@
     <p:sldMasterId id="2147483648" r:id="rId1"/>
   </p:sldMasterIdLst>
   <p:sldIdLst>
-    <p:sldId id="413" r:id="rId2"/>
-    <p:sldId id="414" r:id="rId3"/>
+    <p:sldId id="414" r:id="rId2"/>
+    <p:sldId id="413" r:id="rId3"/>
     <p:sldId id="400" r:id="rId4"/>
+    <p:sldId id="415" r:id="rId5"/>
+    <p:sldId id="416" r:id="rId6"/>
+    <p:sldId id="417" r:id="rId7"/>
+    <p:sldId id="418" r:id="rId8"/>
+    <p:sldId id="419" r:id="rId9"/>
   </p:sldIdLst>
   <p:sldSz cx="12192000" cy="6858000"/>
   <p:notesSz cx="6858000" cy="9144000"/>
@@ -261,7 +266,7 @@
           <a:p>
             <a:fld id="{3E102D2E-813C-461C-9963-687A650C48C0}" type="datetimeFigureOut">
               <a:rPr lang="en-US" smtClean="0"/>
-              <a:t>6/26/2025</a:t>
+              <a:t>9/10/2025</a:t>
             </a:fld>
             <a:endParaRPr lang="en-US"/>
           </a:p>
@@ -459,7 +464,7 @@
           <a:p>
             <a:fld id="{3E102D2E-813C-461C-9963-687A650C48C0}" type="datetimeFigureOut">
               <a:rPr lang="en-US" smtClean="0"/>
-              <a:t>6/26/2025</a:t>
+              <a:t>9/10/2025</a:t>
             </a:fld>
             <a:endParaRPr lang="en-US"/>
           </a:p>
@@ -667,7 +672,7 @@
           <a:p>
             <a:fld id="{3E102D2E-813C-461C-9963-687A650C48C0}" type="datetimeFigureOut">
               <a:rPr lang="en-US" smtClean="0"/>
-              <a:t>6/26/2025</a:t>
+              <a:t>9/10/2025</a:t>
             </a:fld>
             <a:endParaRPr lang="en-US"/>
           </a:p>
@@ -865,7 +870,7 @@
           <a:p>
             <a:fld id="{3E102D2E-813C-461C-9963-687A650C48C0}" type="datetimeFigureOut">
               <a:rPr lang="en-US" smtClean="0"/>
-              <a:t>6/26/2025</a:t>
+              <a:t>9/10/2025</a:t>
             </a:fld>
             <a:endParaRPr lang="en-US"/>
           </a:p>
@@ -1140,7 +1145,7 @@
           <a:p>
             <a:fld id="{3E102D2E-813C-461C-9963-687A650C48C0}" type="datetimeFigureOut">
               <a:rPr lang="en-US" smtClean="0"/>
-              <a:t>6/26/2025</a:t>
+              <a:t>9/10/2025</a:t>
             </a:fld>
             <a:endParaRPr lang="en-US"/>
           </a:p>
@@ -1405,7 +1410,7 @@
           <a:p>
             <a:fld id="{3E102D2E-813C-461C-9963-687A650C48C0}" type="datetimeFigureOut">
               <a:rPr lang="en-US" smtClean="0"/>
-              <a:t>6/26/2025</a:t>
+              <a:t>9/10/2025</a:t>
             </a:fld>
             <a:endParaRPr lang="en-US"/>
           </a:p>
@@ -1817,7 +1822,7 @@
           <a:p>
             <a:fld id="{3E102D2E-813C-461C-9963-687A650C48C0}" type="datetimeFigureOut">
               <a:rPr lang="en-US" smtClean="0"/>
-              <a:t>6/26/2025</a:t>
+              <a:t>9/10/2025</a:t>
             </a:fld>
             <a:endParaRPr lang="en-US"/>
           </a:p>
@@ -1958,7 +1963,7 @@
           <a:p>
             <a:fld id="{3E102D2E-813C-461C-9963-687A650C48C0}" type="datetimeFigureOut">
               <a:rPr lang="en-US" smtClean="0"/>
-              <a:t>6/26/2025</a:t>
+              <a:t>9/10/2025</a:t>
             </a:fld>
             <a:endParaRPr lang="en-US"/>
           </a:p>
@@ -2071,7 +2076,7 @@
           <a:p>
             <a:fld id="{3E102D2E-813C-461C-9963-687A650C48C0}" type="datetimeFigureOut">
               <a:rPr lang="en-US" smtClean="0"/>
-              <a:t>6/26/2025</a:t>
+              <a:t>9/10/2025</a:t>
             </a:fld>
             <a:endParaRPr lang="en-US"/>
           </a:p>
@@ -2382,7 +2387,7 @@
           <a:p>
             <a:fld id="{3E102D2E-813C-461C-9963-687A650C48C0}" type="datetimeFigureOut">
               <a:rPr lang="en-US" smtClean="0"/>
-              <a:t>6/26/2025</a:t>
+              <a:t>9/10/2025</a:t>
             </a:fld>
             <a:endParaRPr lang="en-US"/>
           </a:p>
@@ -2670,7 +2675,7 @@
           <a:p>
             <a:fld id="{3E102D2E-813C-461C-9963-687A650C48C0}" type="datetimeFigureOut">
               <a:rPr lang="en-US" smtClean="0"/>
-              <a:t>6/26/2025</a:t>
+              <a:t>9/10/2025</a:t>
             </a:fld>
             <a:endParaRPr lang="en-US"/>
           </a:p>
@@ -2911,7 +2916,7 @@
           <a:p>
             <a:fld id="{3E102D2E-813C-461C-9963-687A650C48C0}" type="datetimeFigureOut">
               <a:rPr lang="en-US" smtClean="0"/>
-              <a:t>6/26/2025</a:t>
+              <a:t>9/10/2025</a:t>
             </a:fld>
             <a:endParaRPr lang="en-US"/>
           </a:p>
@@ -3319,7 +3324,7 @@
         <p:cNvPr id="1" name="">
           <a:extLst>
             <a:ext uri="{FF2B5EF4-FFF2-40B4-BE49-F238E27FC236}">
-              <a16:creationId xmlns:a16="http://schemas.microsoft.com/office/drawing/2014/main" id="{6A435CBA-29A4-BFD2-CEA7-3290D85ED9F8}"/>
+              <a16:creationId xmlns:a16="http://schemas.microsoft.com/office/drawing/2014/main" id="{E0B23C97-7391-808C-8F93-F1A247B54F0E}"/>
             </a:ext>
           </a:extLst>
         </p:cNvPr>
@@ -3339,7 +3344,7 @@
           <p:cNvPr id="3" name="TextBox 2">
             <a:extLst>
               <a:ext uri="{FF2B5EF4-FFF2-40B4-BE49-F238E27FC236}">
-                <a16:creationId xmlns:a16="http://schemas.microsoft.com/office/drawing/2014/main" id="{A727ABBC-76D0-B81B-760F-26FC272AF479}"/>
+                <a16:creationId xmlns:a16="http://schemas.microsoft.com/office/drawing/2014/main" id="{D9BA728D-9AF8-6C25-DF35-1494919186BC}"/>
               </a:ext>
             </a:extLst>
           </p:cNvPr>
@@ -3369,25 +3374,82 @@
               <a:buNone/>
             </a:pPr>
             <a:r>
-              <a:rPr kumimoji="0" lang="en-US" altLang="en-US" sz="1300" b="0" i="0" u="none" strike="noStrike" cap="none" normalizeH="0" baseline="0">
-                <a:ln>
-                  <a:noFill/>
-                </a:ln>
-                <a:solidFill>
-                  <a:schemeClr val="tx1"/>
-                </a:solidFill>
-                <a:effectLst/>
+              <a:rPr lang="az-Latn-AZ" altLang="en-US" sz="1300">
                 <a:latin typeface="Arial" panose="020B0604020202020204" pitchFamily="34" charset="0"/>
               </a:rPr>
-              <a:t>.</a:t>
-            </a:r>
-          </a:p>
-        </p:txBody>
-      </p:sp>
+              <a:t>Şəkildə göstərilən faylı açaraq həmin fayldan lazım olan </a:t>
+            </a:r>
+            <a:r>
+              <a:rPr lang="az-Latn-AZ" altLang="en-US" sz="1300" b="1">
+                <a:latin typeface="Arial" panose="020B0604020202020204" pitchFamily="34" charset="0"/>
+              </a:rPr>
+              <a:t>CSS</a:t>
+            </a:r>
+            <a:r>
+              <a:rPr lang="az-Latn-AZ" altLang="en-US" sz="1300">
+                <a:latin typeface="Arial" panose="020B0604020202020204" pitchFamily="34" charset="0"/>
+              </a:rPr>
+              <a:t> və </a:t>
+            </a:r>
+            <a:r>
+              <a:rPr lang="az-Latn-AZ" altLang="en-US" sz="1300" b="1">
+                <a:latin typeface="Arial" panose="020B0604020202020204" pitchFamily="34" charset="0"/>
+              </a:rPr>
+              <a:t>JS</a:t>
+            </a:r>
+            <a:r>
+              <a:rPr lang="az-Latn-AZ" altLang="en-US" sz="1300">
+                <a:latin typeface="Arial" panose="020B0604020202020204" pitchFamily="34" charset="0"/>
+              </a:rPr>
+              <a:t> linkləri götürürük.</a:t>
+            </a:r>
+            <a:endParaRPr kumimoji="0" lang="en-US" altLang="en-US" sz="1300" b="0" i="0" u="none" strike="noStrike" cap="none" normalizeH="0" baseline="0">
+              <a:ln>
+                <a:noFill/>
+              </a:ln>
+              <a:solidFill>
+                <a:schemeClr val="tx1"/>
+              </a:solidFill>
+              <a:effectLst/>
+              <a:latin typeface="Arial" panose="020B0604020202020204" pitchFamily="34" charset="0"/>
+            </a:endParaRPr>
+          </a:p>
+        </p:txBody>
+      </p:sp>
+      <p:pic>
+        <p:nvPicPr>
+          <p:cNvPr id="4" name="Picture 3">
+            <a:extLst>
+              <a:ext uri="{FF2B5EF4-FFF2-40B4-BE49-F238E27FC236}">
+                <a16:creationId xmlns:a16="http://schemas.microsoft.com/office/drawing/2014/main" id="{B582C9A4-6FE8-2CDF-96AC-44B5BDF8858F}"/>
+              </a:ext>
+            </a:extLst>
+          </p:cNvPr>
+          <p:cNvPicPr>
+            <a:picLocks noChangeAspect="1"/>
+          </p:cNvPicPr>
+          <p:nvPr/>
+        </p:nvPicPr>
+        <p:blipFill>
+          <a:blip r:embed="rId2"/>
+          <a:stretch>
+            <a:fillRect/>
+          </a:stretch>
+        </p:blipFill>
+        <p:spPr>
+          <a:xfrm>
+            <a:off x="5923675" y="1723308"/>
+            <a:ext cx="6268325" cy="5134692"/>
+          </a:xfrm>
+          <a:prstGeom prst="rect">
+            <a:avLst/>
+          </a:prstGeom>
+        </p:spPr>
+      </p:pic>
     </p:spTree>
     <p:extLst>
       <p:ext uri="{BB962C8B-B14F-4D97-AF65-F5344CB8AC3E}">
-        <p14:creationId xmlns:p14="http://schemas.microsoft.com/office/powerpoint/2010/main" val="3863838039"/>
+        <p14:creationId xmlns:p14="http://schemas.microsoft.com/office/powerpoint/2010/main" val="4233252692"/>
       </p:ext>
     </p:extLst>
   </p:cSld>
@@ -3405,7 +3467,7 @@
         <p:cNvPr id="1" name="">
           <a:extLst>
             <a:ext uri="{FF2B5EF4-FFF2-40B4-BE49-F238E27FC236}">
-              <a16:creationId xmlns:a16="http://schemas.microsoft.com/office/drawing/2014/main" id="{E0B23C97-7391-808C-8F93-F1A247B54F0E}"/>
+              <a16:creationId xmlns:a16="http://schemas.microsoft.com/office/drawing/2014/main" id="{6A435CBA-29A4-BFD2-CEA7-3290D85ED9F8}"/>
             </a:ext>
           </a:extLst>
         </p:cNvPr>
@@ -3425,7 +3487,7 @@
           <p:cNvPr id="3" name="TextBox 2">
             <a:extLst>
               <a:ext uri="{FF2B5EF4-FFF2-40B4-BE49-F238E27FC236}">
-                <a16:creationId xmlns:a16="http://schemas.microsoft.com/office/drawing/2014/main" id="{D9BA728D-9AF8-6C25-DF35-1494919186BC}"/>
+                <a16:creationId xmlns:a16="http://schemas.microsoft.com/office/drawing/2014/main" id="{A727ABBC-76D0-B81B-760F-26FC272AF479}"/>
               </a:ext>
             </a:extLst>
           </p:cNvPr>
@@ -3455,25 +3517,64 @@
               <a:buNone/>
             </a:pPr>
             <a:r>
-              <a:rPr kumimoji="0" lang="en-US" altLang="en-US" sz="1300" b="0" i="0" u="none" strike="noStrike" cap="none" normalizeH="0" baseline="0">
-                <a:ln>
-                  <a:noFill/>
-                </a:ln>
-                <a:solidFill>
-                  <a:schemeClr val="tx1"/>
-                </a:solidFill>
-                <a:effectLst/>
+              <a:rPr lang="en-US" altLang="en-US" sz="1300">
                 <a:latin typeface="Arial" panose="020B0604020202020204" pitchFamily="34" charset="0"/>
               </a:rPr>
-              <a:t>.</a:t>
-            </a:r>
-          </a:p>
-        </p:txBody>
-      </p:sp>
+              <a:t>resources\views\admin\layouts\master.blade.php</a:t>
+            </a:r>
+            <a:r>
+              <a:rPr lang="az-Latn-AZ" altLang="en-US" sz="1300">
+                <a:latin typeface="Arial" panose="020B0604020202020204" pitchFamily="34" charset="0"/>
+              </a:rPr>
+              <a:t> - həmin linki bu fayla qoyuruq.</a:t>
+            </a:r>
+            <a:endParaRPr kumimoji="0" lang="en-US" altLang="en-US" sz="1300" b="0" i="0" u="none" strike="noStrike" cap="none" normalizeH="0" baseline="0">
+              <a:ln>
+                <a:noFill/>
+              </a:ln>
+              <a:solidFill>
+                <a:schemeClr val="tx1"/>
+              </a:solidFill>
+              <a:effectLst/>
+              <a:latin typeface="Arial" panose="020B0604020202020204" pitchFamily="34" charset="0"/>
+            </a:endParaRPr>
+          </a:p>
+        </p:txBody>
+      </p:sp>
+      <p:pic>
+        <p:nvPicPr>
+          <p:cNvPr id="4" name="Picture 3">
+            <a:extLst>
+              <a:ext uri="{FF2B5EF4-FFF2-40B4-BE49-F238E27FC236}">
+                <a16:creationId xmlns:a16="http://schemas.microsoft.com/office/drawing/2014/main" id="{7363D4A1-8881-3035-C892-6C8D00A54137}"/>
+              </a:ext>
+            </a:extLst>
+          </p:cNvPr>
+          <p:cNvPicPr>
+            <a:picLocks noChangeAspect="1"/>
+          </p:cNvPicPr>
+          <p:nvPr/>
+        </p:nvPicPr>
+        <p:blipFill>
+          <a:blip r:embed="rId2"/>
+          <a:stretch>
+            <a:fillRect/>
+          </a:stretch>
+        </p:blipFill>
+        <p:spPr>
+          <a:xfrm>
+            <a:off x="1228436" y="1027936"/>
+            <a:ext cx="10963564" cy="5830064"/>
+          </a:xfrm>
+          <a:prstGeom prst="rect">
+            <a:avLst/>
+          </a:prstGeom>
+        </p:spPr>
+      </p:pic>
     </p:spTree>
     <p:extLst>
       <p:ext uri="{BB962C8B-B14F-4D97-AF65-F5344CB8AC3E}">
-        <p14:creationId xmlns:p14="http://schemas.microsoft.com/office/powerpoint/2010/main" val="4233252692"/>
+        <p14:creationId xmlns:p14="http://schemas.microsoft.com/office/powerpoint/2010/main" val="3863838039"/>
       </p:ext>
     </p:extLst>
   </p:cSld>
@@ -3541,6 +3642,615 @@
               <a:buNone/>
             </a:pPr>
             <a:r>
+              <a:rPr lang="en-US" altLang="en-US" sz="1300">
+                <a:latin typeface="Arial" panose="020B0604020202020204" pitchFamily="34" charset="0"/>
+              </a:rPr>
+              <a:t>resources\views\admin\layouts\master.blade.php</a:t>
+            </a:r>
+            <a:endParaRPr kumimoji="0" lang="en-US" altLang="en-US" sz="1300" b="0" i="0" u="none" strike="noStrike" cap="none" normalizeH="0" baseline="0">
+              <a:ln>
+                <a:noFill/>
+              </a:ln>
+              <a:solidFill>
+                <a:schemeClr val="tx1"/>
+              </a:solidFill>
+              <a:effectLst/>
+              <a:latin typeface="Arial" panose="020B0604020202020204" pitchFamily="34" charset="0"/>
+            </a:endParaRPr>
+          </a:p>
+        </p:txBody>
+      </p:sp>
+      <p:pic>
+        <p:nvPicPr>
+          <p:cNvPr id="4" name="Picture 3">
+            <a:extLst>
+              <a:ext uri="{FF2B5EF4-FFF2-40B4-BE49-F238E27FC236}">
+                <a16:creationId xmlns:a16="http://schemas.microsoft.com/office/drawing/2014/main" id="{6725CF94-69D5-B20D-6EC2-875E670CED87}"/>
+              </a:ext>
+            </a:extLst>
+          </p:cNvPr>
+          <p:cNvPicPr>
+            <a:picLocks noChangeAspect="1"/>
+          </p:cNvPicPr>
+          <p:nvPr/>
+        </p:nvPicPr>
+        <p:blipFill>
+          <a:blip r:embed="rId2"/>
+          <a:stretch>
+            <a:fillRect/>
+          </a:stretch>
+        </p:blipFill>
+        <p:spPr>
+          <a:xfrm>
+            <a:off x="0" y="957176"/>
+            <a:ext cx="12192000" cy="5900824"/>
+          </a:xfrm>
+          <a:prstGeom prst="rect">
+            <a:avLst/>
+          </a:prstGeom>
+        </p:spPr>
+      </p:pic>
+    </p:spTree>
+    <p:extLst>
+      <p:ext uri="{BB962C8B-B14F-4D97-AF65-F5344CB8AC3E}">
+        <p14:creationId xmlns:p14="http://schemas.microsoft.com/office/powerpoint/2010/main" val="3095838342"/>
+      </p:ext>
+    </p:extLst>
+  </p:cSld>
+  <p:clrMapOvr>
+    <a:masterClrMapping/>
+  </p:clrMapOvr>
+</p:sld>
+</file>
+
+<file path=ppt/slides/slide4.xml><?xml version="1.0" encoding="utf-8"?>
+<p:sld xmlns:a="http://schemas.openxmlformats.org/drawingml/2006/main" xmlns:r="http://schemas.openxmlformats.org/officeDocument/2006/relationships" xmlns:p="http://schemas.openxmlformats.org/presentationml/2006/main">
+  <p:cSld>
+    <p:spTree>
+      <p:nvGrpSpPr>
+        <p:cNvPr id="1" name="">
+          <a:extLst>
+            <a:ext uri="{FF2B5EF4-FFF2-40B4-BE49-F238E27FC236}">
+              <a16:creationId xmlns:a16="http://schemas.microsoft.com/office/drawing/2014/main" id="{ECD0233D-535D-6024-CAB3-F794307B5743}"/>
+            </a:ext>
+          </a:extLst>
+        </p:cNvPr>
+        <p:cNvGrpSpPr/>
+        <p:nvPr/>
+      </p:nvGrpSpPr>
+      <p:grpSpPr>
+        <a:xfrm>
+          <a:off x="0" y="0"/>
+          <a:ext cx="0" cy="0"/>
+          <a:chOff x="0" y="0"/>
+          <a:chExt cx="0" cy="0"/>
+        </a:xfrm>
+      </p:grpSpPr>
+      <p:sp>
+        <p:nvSpPr>
+          <p:cNvPr id="3" name="TextBox 2">
+            <a:extLst>
+              <a:ext uri="{FF2B5EF4-FFF2-40B4-BE49-F238E27FC236}">
+                <a16:creationId xmlns:a16="http://schemas.microsoft.com/office/drawing/2014/main" id="{B8310FC4-7EB1-68C2-5537-DF7BE5A7628B}"/>
+              </a:ext>
+            </a:extLst>
+          </p:cNvPr>
+          <p:cNvSpPr txBox="1"/>
+          <p:nvPr/>
+        </p:nvSpPr>
+        <p:spPr>
+          <a:xfrm>
+            <a:off x="217714" y="255046"/>
+            <a:ext cx="11756571" cy="355354"/>
+          </a:xfrm>
+          <a:prstGeom prst="rect">
+            <a:avLst/>
+          </a:prstGeom>
+          <a:noFill/>
+        </p:spPr>
+        <p:txBody>
+          <a:bodyPr wrap="square">
+            <a:spAutoFit/>
+          </a:bodyPr>
+          <a:lstStyle/>
+          <a:p>
+            <a:pPr>
+              <a:lnSpc>
+                <a:spcPct val="150000"/>
+              </a:lnSpc>
+              <a:buNone/>
+            </a:pPr>
+            <a:r>
+              <a:rPr lang="en-US" altLang="en-US" sz="1300">
+                <a:latin typeface="Arial" panose="020B0604020202020204" pitchFamily="34" charset="0"/>
+              </a:rPr>
+              <a:t>resources\views\admin\product\create.blade.php</a:t>
+            </a:r>
+            <a:endParaRPr kumimoji="0" lang="en-US" altLang="en-US" sz="1300" b="0" i="0" u="none" strike="noStrike" cap="none" normalizeH="0" baseline="0">
+              <a:ln>
+                <a:noFill/>
+              </a:ln>
+              <a:solidFill>
+                <a:schemeClr val="tx1"/>
+              </a:solidFill>
+              <a:effectLst/>
+              <a:latin typeface="Arial" panose="020B0604020202020204" pitchFamily="34" charset="0"/>
+            </a:endParaRPr>
+          </a:p>
+        </p:txBody>
+      </p:sp>
+      <p:pic>
+        <p:nvPicPr>
+          <p:cNvPr id="6" name="Picture 5">
+            <a:extLst>
+              <a:ext uri="{FF2B5EF4-FFF2-40B4-BE49-F238E27FC236}">
+                <a16:creationId xmlns:a16="http://schemas.microsoft.com/office/drawing/2014/main" id="{9CC67790-45AE-CD26-CAC8-C4AF1903E376}"/>
+              </a:ext>
+            </a:extLst>
+          </p:cNvPr>
+          <p:cNvPicPr>
+            <a:picLocks noChangeAspect="1"/>
+          </p:cNvPicPr>
+          <p:nvPr/>
+        </p:nvPicPr>
+        <p:blipFill>
+          <a:blip r:embed="rId2"/>
+          <a:stretch>
+            <a:fillRect/>
+          </a:stretch>
+        </p:blipFill>
+        <p:spPr>
+          <a:xfrm>
+            <a:off x="4128655" y="915582"/>
+            <a:ext cx="8063345" cy="5942418"/>
+          </a:xfrm>
+          <a:prstGeom prst="rect">
+            <a:avLst/>
+          </a:prstGeom>
+        </p:spPr>
+      </p:pic>
+    </p:spTree>
+    <p:extLst>
+      <p:ext uri="{BB962C8B-B14F-4D97-AF65-F5344CB8AC3E}">
+        <p14:creationId xmlns:p14="http://schemas.microsoft.com/office/powerpoint/2010/main" val="534824817"/>
+      </p:ext>
+    </p:extLst>
+  </p:cSld>
+  <p:clrMapOvr>
+    <a:masterClrMapping/>
+  </p:clrMapOvr>
+</p:sld>
+</file>
+
+<file path=ppt/slides/slide5.xml><?xml version="1.0" encoding="utf-8"?>
+<p:sld xmlns:a="http://schemas.openxmlformats.org/drawingml/2006/main" xmlns:r="http://schemas.openxmlformats.org/officeDocument/2006/relationships" xmlns:p="http://schemas.openxmlformats.org/presentationml/2006/main">
+  <p:cSld>
+    <p:spTree>
+      <p:nvGrpSpPr>
+        <p:cNvPr id="1" name="">
+          <a:extLst>
+            <a:ext uri="{FF2B5EF4-FFF2-40B4-BE49-F238E27FC236}">
+              <a16:creationId xmlns:a16="http://schemas.microsoft.com/office/drawing/2014/main" id="{4DC4CC7D-F877-E3B9-E026-9DB96892D986}"/>
+            </a:ext>
+          </a:extLst>
+        </p:cNvPr>
+        <p:cNvGrpSpPr/>
+        <p:nvPr/>
+      </p:nvGrpSpPr>
+      <p:grpSpPr>
+        <a:xfrm>
+          <a:off x="0" y="0"/>
+          <a:ext cx="0" cy="0"/>
+          <a:chOff x="0" y="0"/>
+          <a:chExt cx="0" cy="0"/>
+        </a:xfrm>
+      </p:grpSpPr>
+      <p:sp>
+        <p:nvSpPr>
+          <p:cNvPr id="3" name="TextBox 2">
+            <a:extLst>
+              <a:ext uri="{FF2B5EF4-FFF2-40B4-BE49-F238E27FC236}">
+                <a16:creationId xmlns:a16="http://schemas.microsoft.com/office/drawing/2014/main" id="{88E02C60-2698-1525-2AE1-2613C8D6051E}"/>
+              </a:ext>
+            </a:extLst>
+          </p:cNvPr>
+          <p:cNvSpPr txBox="1"/>
+          <p:nvPr/>
+        </p:nvSpPr>
+        <p:spPr>
+          <a:xfrm>
+            <a:off x="217714" y="255046"/>
+            <a:ext cx="11756571" cy="355354"/>
+          </a:xfrm>
+          <a:prstGeom prst="rect">
+            <a:avLst/>
+          </a:prstGeom>
+          <a:noFill/>
+        </p:spPr>
+        <p:txBody>
+          <a:bodyPr wrap="square">
+            <a:spAutoFit/>
+          </a:bodyPr>
+          <a:lstStyle/>
+          <a:p>
+            <a:pPr>
+              <a:lnSpc>
+                <a:spcPct val="150000"/>
+              </a:lnSpc>
+              <a:buNone/>
+            </a:pPr>
+            <a:r>
+              <a:rPr lang="en-US" altLang="en-US" sz="1300">
+                <a:latin typeface="Arial" panose="020B0604020202020204" pitchFamily="34" charset="0"/>
+              </a:rPr>
+              <a:t>resources\views\admin\product\create.blade.php</a:t>
+            </a:r>
+            <a:endParaRPr kumimoji="0" lang="en-US" altLang="en-US" sz="1300" b="0" i="0" u="none" strike="noStrike" cap="none" normalizeH="0" baseline="0">
+              <a:ln>
+                <a:noFill/>
+              </a:ln>
+              <a:solidFill>
+                <a:schemeClr val="tx1"/>
+              </a:solidFill>
+              <a:effectLst/>
+              <a:latin typeface="Arial" panose="020B0604020202020204" pitchFamily="34" charset="0"/>
+            </a:endParaRPr>
+          </a:p>
+        </p:txBody>
+      </p:sp>
+      <p:pic>
+        <p:nvPicPr>
+          <p:cNvPr id="4" name="Picture 3">
+            <a:extLst>
+              <a:ext uri="{FF2B5EF4-FFF2-40B4-BE49-F238E27FC236}">
+                <a16:creationId xmlns:a16="http://schemas.microsoft.com/office/drawing/2014/main" id="{7C8755A1-58CB-9C9D-597F-40E54C3DF470}"/>
+              </a:ext>
+            </a:extLst>
+          </p:cNvPr>
+          <p:cNvPicPr>
+            <a:picLocks noChangeAspect="1"/>
+          </p:cNvPicPr>
+          <p:nvPr/>
+        </p:nvPicPr>
+        <p:blipFill>
+          <a:blip r:embed="rId2"/>
+          <a:stretch>
+            <a:fillRect/>
+          </a:stretch>
+        </p:blipFill>
+        <p:spPr>
+          <a:xfrm>
+            <a:off x="5189258" y="0"/>
+            <a:ext cx="7002742" cy="6858000"/>
+          </a:xfrm>
+          <a:prstGeom prst="rect">
+            <a:avLst/>
+          </a:prstGeom>
+        </p:spPr>
+      </p:pic>
+    </p:spTree>
+    <p:extLst>
+      <p:ext uri="{BB962C8B-B14F-4D97-AF65-F5344CB8AC3E}">
+        <p14:creationId xmlns:p14="http://schemas.microsoft.com/office/powerpoint/2010/main" val="1016037798"/>
+      </p:ext>
+    </p:extLst>
+  </p:cSld>
+  <p:clrMapOvr>
+    <a:masterClrMapping/>
+  </p:clrMapOvr>
+</p:sld>
+</file>
+
+<file path=ppt/slides/slide6.xml><?xml version="1.0" encoding="utf-8"?>
+<p:sld xmlns:a="http://schemas.openxmlformats.org/drawingml/2006/main" xmlns:r="http://schemas.openxmlformats.org/officeDocument/2006/relationships" xmlns:p="http://schemas.openxmlformats.org/presentationml/2006/main">
+  <p:cSld>
+    <p:spTree>
+      <p:nvGrpSpPr>
+        <p:cNvPr id="1" name="">
+          <a:extLst>
+            <a:ext uri="{FF2B5EF4-FFF2-40B4-BE49-F238E27FC236}">
+              <a16:creationId xmlns:a16="http://schemas.microsoft.com/office/drawing/2014/main" id="{3071C82A-B2F4-B8CA-B48A-315B3AFCF75E}"/>
+            </a:ext>
+          </a:extLst>
+        </p:cNvPr>
+        <p:cNvGrpSpPr/>
+        <p:nvPr/>
+      </p:nvGrpSpPr>
+      <p:grpSpPr>
+        <a:xfrm>
+          <a:off x="0" y="0"/>
+          <a:ext cx="0" cy="0"/>
+          <a:chOff x="0" y="0"/>
+          <a:chExt cx="0" cy="0"/>
+        </a:xfrm>
+      </p:grpSpPr>
+      <p:sp>
+        <p:nvSpPr>
+          <p:cNvPr id="3" name="TextBox 2">
+            <a:extLst>
+              <a:ext uri="{FF2B5EF4-FFF2-40B4-BE49-F238E27FC236}">
+                <a16:creationId xmlns:a16="http://schemas.microsoft.com/office/drawing/2014/main" id="{67228F75-AD07-ECA8-99ED-F849311E5113}"/>
+              </a:ext>
+            </a:extLst>
+          </p:cNvPr>
+          <p:cNvSpPr txBox="1"/>
+          <p:nvPr/>
+        </p:nvSpPr>
+        <p:spPr>
+          <a:xfrm>
+            <a:off x="217714" y="255046"/>
+            <a:ext cx="11756571" cy="355354"/>
+          </a:xfrm>
+          <a:prstGeom prst="rect">
+            <a:avLst/>
+          </a:prstGeom>
+          <a:noFill/>
+        </p:spPr>
+        <p:txBody>
+          <a:bodyPr wrap="square">
+            <a:spAutoFit/>
+          </a:bodyPr>
+          <a:lstStyle/>
+          <a:p>
+            <a:pPr>
+              <a:lnSpc>
+                <a:spcPct val="150000"/>
+              </a:lnSpc>
+              <a:buNone/>
+            </a:pPr>
+            <a:r>
+              <a:rPr lang="en-US" altLang="en-US" sz="1300">
+                <a:latin typeface="Arial" panose="020B0604020202020204" pitchFamily="34" charset="0"/>
+              </a:rPr>
+              <a:t>resources\views\admin\product\create.blade.php</a:t>
+            </a:r>
+            <a:endParaRPr kumimoji="0" lang="en-US" altLang="en-US" sz="1300" b="0" i="0" u="none" strike="noStrike" cap="none" normalizeH="0" baseline="0">
+              <a:ln>
+                <a:noFill/>
+              </a:ln>
+              <a:solidFill>
+                <a:schemeClr val="tx1"/>
+              </a:solidFill>
+              <a:effectLst/>
+              <a:latin typeface="Arial" panose="020B0604020202020204" pitchFamily="34" charset="0"/>
+            </a:endParaRPr>
+          </a:p>
+        </p:txBody>
+      </p:sp>
+      <p:pic>
+        <p:nvPicPr>
+          <p:cNvPr id="4" name="Picture 3">
+            <a:extLst>
+              <a:ext uri="{FF2B5EF4-FFF2-40B4-BE49-F238E27FC236}">
+                <a16:creationId xmlns:a16="http://schemas.microsoft.com/office/drawing/2014/main" id="{00F6441C-A5C1-D6F0-3E33-57E92BAD2E56}"/>
+              </a:ext>
+            </a:extLst>
+          </p:cNvPr>
+          <p:cNvPicPr>
+            <a:picLocks noChangeAspect="1"/>
+          </p:cNvPicPr>
+          <p:nvPr/>
+        </p:nvPicPr>
+        <p:blipFill>
+          <a:blip r:embed="rId2"/>
+          <a:stretch>
+            <a:fillRect/>
+          </a:stretch>
+        </p:blipFill>
+        <p:spPr>
+          <a:xfrm>
+            <a:off x="4082473" y="888586"/>
+            <a:ext cx="8109527" cy="5969414"/>
+          </a:xfrm>
+          <a:prstGeom prst="rect">
+            <a:avLst/>
+          </a:prstGeom>
+        </p:spPr>
+      </p:pic>
+    </p:spTree>
+    <p:extLst>
+      <p:ext uri="{BB962C8B-B14F-4D97-AF65-F5344CB8AC3E}">
+        <p14:creationId xmlns:p14="http://schemas.microsoft.com/office/powerpoint/2010/main" val="1989978780"/>
+      </p:ext>
+    </p:extLst>
+  </p:cSld>
+  <p:clrMapOvr>
+    <a:masterClrMapping/>
+  </p:clrMapOvr>
+</p:sld>
+</file>
+
+<file path=ppt/slides/slide7.xml><?xml version="1.0" encoding="utf-8"?>
+<p:sld xmlns:a="http://schemas.openxmlformats.org/drawingml/2006/main" xmlns:r="http://schemas.openxmlformats.org/officeDocument/2006/relationships" xmlns:p="http://schemas.openxmlformats.org/presentationml/2006/main">
+  <p:cSld>
+    <p:spTree>
+      <p:nvGrpSpPr>
+        <p:cNvPr id="1" name="">
+          <a:extLst>
+            <a:ext uri="{FF2B5EF4-FFF2-40B4-BE49-F238E27FC236}">
+              <a16:creationId xmlns:a16="http://schemas.microsoft.com/office/drawing/2014/main" id="{0BF7CF41-8346-7B04-637A-7935A9669317}"/>
+            </a:ext>
+          </a:extLst>
+        </p:cNvPr>
+        <p:cNvGrpSpPr/>
+        <p:nvPr/>
+      </p:nvGrpSpPr>
+      <p:grpSpPr>
+        <a:xfrm>
+          <a:off x="0" y="0"/>
+          <a:ext cx="0" cy="0"/>
+          <a:chOff x="0" y="0"/>
+          <a:chExt cx="0" cy="0"/>
+        </a:xfrm>
+      </p:grpSpPr>
+      <p:sp>
+        <p:nvSpPr>
+          <p:cNvPr id="3" name="TextBox 2">
+            <a:extLst>
+              <a:ext uri="{FF2B5EF4-FFF2-40B4-BE49-F238E27FC236}">
+                <a16:creationId xmlns:a16="http://schemas.microsoft.com/office/drawing/2014/main" id="{B3EACE63-EBA0-B436-375F-8ACC2DAC1F2D}"/>
+              </a:ext>
+            </a:extLst>
+          </p:cNvPr>
+          <p:cNvSpPr txBox="1"/>
+          <p:nvPr/>
+        </p:nvSpPr>
+        <p:spPr>
+          <a:xfrm>
+            <a:off x="217714" y="199628"/>
+            <a:ext cx="11756571" cy="355354"/>
+          </a:xfrm>
+          <a:prstGeom prst="rect">
+            <a:avLst/>
+          </a:prstGeom>
+          <a:noFill/>
+        </p:spPr>
+        <p:txBody>
+          <a:bodyPr wrap="square">
+            <a:spAutoFit/>
+          </a:bodyPr>
+          <a:lstStyle/>
+          <a:p>
+            <a:pPr>
+              <a:lnSpc>
+                <a:spcPct val="150000"/>
+              </a:lnSpc>
+              <a:buNone/>
+            </a:pPr>
+            <a:r>
+              <a:rPr lang="az-Latn-AZ" altLang="en-US" sz="1300">
+                <a:latin typeface="Arial" panose="020B0604020202020204" pitchFamily="34" charset="0"/>
+              </a:rPr>
+              <a:t>İndiki nəticə</a:t>
+            </a:r>
+            <a:endParaRPr kumimoji="0" lang="en-US" altLang="en-US" sz="1300" b="0" i="0" u="none" strike="noStrike" cap="none" normalizeH="0" baseline="0">
+              <a:ln>
+                <a:noFill/>
+              </a:ln>
+              <a:solidFill>
+                <a:schemeClr val="tx1"/>
+              </a:solidFill>
+              <a:effectLst/>
+              <a:latin typeface="Arial" panose="020B0604020202020204" pitchFamily="34" charset="0"/>
+            </a:endParaRPr>
+          </a:p>
+        </p:txBody>
+      </p:sp>
+      <p:pic>
+        <p:nvPicPr>
+          <p:cNvPr id="4" name="Picture 3">
+            <a:extLst>
+              <a:ext uri="{FF2B5EF4-FFF2-40B4-BE49-F238E27FC236}">
+                <a16:creationId xmlns:a16="http://schemas.microsoft.com/office/drawing/2014/main" id="{9223EE52-BED2-5E48-3830-E003E7704FAB}"/>
+              </a:ext>
+            </a:extLst>
+          </p:cNvPr>
+          <p:cNvPicPr>
+            <a:picLocks noChangeAspect="1"/>
+          </p:cNvPicPr>
+          <p:nvPr/>
+        </p:nvPicPr>
+        <p:blipFill>
+          <a:blip r:embed="rId2"/>
+          <a:stretch>
+            <a:fillRect/>
+          </a:stretch>
+        </p:blipFill>
+        <p:spPr>
+          <a:xfrm>
+            <a:off x="0" y="707884"/>
+            <a:ext cx="12192000" cy="6150116"/>
+          </a:xfrm>
+          <a:prstGeom prst="rect">
+            <a:avLst/>
+          </a:prstGeom>
+          <a:ln w="38100" cap="sq">
+            <a:solidFill>
+              <a:srgbClr val="000000"/>
+            </a:solidFill>
+            <a:prstDash val="solid"/>
+            <a:miter lim="800000"/>
+          </a:ln>
+          <a:effectLst>
+            <a:outerShdw blurRad="50800" dist="38100" dir="2700000" algn="tl" rotWithShape="0">
+              <a:srgbClr val="000000">
+                <a:alpha val="43000"/>
+              </a:srgbClr>
+            </a:outerShdw>
+          </a:effectLst>
+        </p:spPr>
+      </p:pic>
+    </p:spTree>
+    <p:extLst>
+      <p:ext uri="{BB962C8B-B14F-4D97-AF65-F5344CB8AC3E}">
+        <p14:creationId xmlns:p14="http://schemas.microsoft.com/office/powerpoint/2010/main" val="271608137"/>
+      </p:ext>
+    </p:extLst>
+  </p:cSld>
+  <p:clrMapOvr>
+    <a:masterClrMapping/>
+  </p:clrMapOvr>
+</p:sld>
+</file>
+
+<file path=ppt/slides/slide8.xml><?xml version="1.0" encoding="utf-8"?>
+<p:sld xmlns:a="http://schemas.openxmlformats.org/drawingml/2006/main" xmlns:r="http://schemas.openxmlformats.org/officeDocument/2006/relationships" xmlns:p="http://schemas.openxmlformats.org/presentationml/2006/main">
+  <p:cSld>
+    <p:spTree>
+      <p:nvGrpSpPr>
+        <p:cNvPr id="1" name="">
+          <a:extLst>
+            <a:ext uri="{FF2B5EF4-FFF2-40B4-BE49-F238E27FC236}">
+              <a16:creationId xmlns:a16="http://schemas.microsoft.com/office/drawing/2014/main" id="{A2588346-CC2A-6893-2A95-8F5D1CEBD240}"/>
+            </a:ext>
+          </a:extLst>
+        </p:cNvPr>
+        <p:cNvGrpSpPr/>
+        <p:nvPr/>
+      </p:nvGrpSpPr>
+      <p:grpSpPr>
+        <a:xfrm>
+          <a:off x="0" y="0"/>
+          <a:ext cx="0" cy="0"/>
+          <a:chOff x="0" y="0"/>
+          <a:chExt cx="0" cy="0"/>
+        </a:xfrm>
+      </p:grpSpPr>
+      <p:sp>
+        <p:nvSpPr>
+          <p:cNvPr id="3" name="TextBox 2">
+            <a:extLst>
+              <a:ext uri="{FF2B5EF4-FFF2-40B4-BE49-F238E27FC236}">
+                <a16:creationId xmlns:a16="http://schemas.microsoft.com/office/drawing/2014/main" id="{78935431-423F-BBE0-066B-549668B0ED38}"/>
+              </a:ext>
+            </a:extLst>
+          </p:cNvPr>
+          <p:cNvSpPr txBox="1"/>
+          <p:nvPr/>
+        </p:nvSpPr>
+        <p:spPr>
+          <a:xfrm>
+            <a:off x="217714" y="255046"/>
+            <a:ext cx="11756571" cy="355354"/>
+          </a:xfrm>
+          <a:prstGeom prst="rect">
+            <a:avLst/>
+          </a:prstGeom>
+          <a:noFill/>
+        </p:spPr>
+        <p:txBody>
+          <a:bodyPr wrap="square">
+            <a:spAutoFit/>
+          </a:bodyPr>
+          <a:lstStyle/>
+          <a:p>
+            <a:pPr>
+              <a:lnSpc>
+                <a:spcPct val="150000"/>
+              </a:lnSpc>
+              <a:buNone/>
+            </a:pPr>
+            <a:r>
               <a:rPr kumimoji="0" lang="en-US" altLang="en-US" sz="1300" b="0" i="0" u="none" strike="noStrike" cap="none" normalizeH="0" baseline="0">
                 <a:ln>
                   <a:noFill/>
@@ -3559,7 +4269,7 @@
     </p:spTree>
     <p:extLst>
       <p:ext uri="{BB962C8B-B14F-4D97-AF65-F5344CB8AC3E}">
-        <p14:creationId xmlns:p14="http://schemas.microsoft.com/office/powerpoint/2010/main" val="3095838342"/>
+        <p14:creationId xmlns:p14="http://schemas.microsoft.com/office/powerpoint/2010/main" val="4144993062"/>
       </p:ext>
     </p:extLst>
   </p:cSld>

</xml_diff>